<commit_message>
data-eng 4-2 캡처 21장 · 덱 5(실습점검 신설) — 2026-10-15 실측
</commit_message>
<xml_diff>
--- a/data-eng/decks/w4d2s1.pptx
+++ b/data-eng/decks/w4d2s1.pptx
@@ -3099,7 +3099,7 @@
       <p:grpSpPr/>
       <p:sp>
         <p:nvSpPr>
-          <p:cNvPr id="2" name="Oval 1"/>
+          <p:cNvPr id="2" name="deckgen:decor"/>
           <p:cNvSpPr/>
           <p:nvPr/>
         </p:nvSpPr>
@@ -3129,7 +3129,7 @@
       </p:sp>
       <p:sp>
         <p:nvSpPr>
-          <p:cNvPr id="3" name="Oval 2"/>
+          <p:cNvPr id="3" name="deckgen:decor"/>
           <p:cNvSpPr/>
           <p:nvPr/>
         </p:nvSpPr>
@@ -3159,7 +3159,7 @@
       </p:sp>
       <p:sp>
         <p:nvSpPr>
-          <p:cNvPr id="4" name="Oval 3"/>
+          <p:cNvPr id="4" name="deckgen:decor"/>
           <p:cNvSpPr/>
           <p:nvPr/>
         </p:nvSpPr>
@@ -3189,7 +3189,7 @@
       </p:sp>
       <p:sp>
         <p:nvSpPr>
-          <p:cNvPr id="5" name="Rectangle 4"/>
+          <p:cNvPr id="5" name="deckgen:decor"/>
           <p:cNvSpPr/>
           <p:nvPr/>
         </p:nvSpPr>
@@ -3219,7 +3219,7 @@
       </p:sp>
       <p:sp>
         <p:nvSpPr>
-          <p:cNvPr id="6" name="Oval 5"/>
+          <p:cNvPr id="6" name="deckgen:decor"/>
           <p:cNvSpPr/>
           <p:nvPr/>
         </p:nvSpPr>
@@ -3249,7 +3249,7 @@
       </p:sp>
       <p:sp>
         <p:nvSpPr>
-          <p:cNvPr id="7" name="Oval 6"/>
+          <p:cNvPr id="7" name="deckgen:decor"/>
           <p:cNvSpPr/>
           <p:nvPr/>
         </p:nvSpPr>
@@ -3279,7 +3279,7 @@
       </p:sp>
       <p:sp>
         <p:nvSpPr>
-          <p:cNvPr id="8" name="Oval 7"/>
+          <p:cNvPr id="8" name="deckgen:decor"/>
           <p:cNvSpPr/>
           <p:nvPr/>
         </p:nvSpPr>
@@ -3309,7 +3309,7 @@
       </p:sp>
       <p:sp>
         <p:nvSpPr>
-          <p:cNvPr id="9" name="Oval 8"/>
+          <p:cNvPr id="9" name="deckgen:decor"/>
           <p:cNvSpPr/>
           <p:nvPr/>
         </p:nvSpPr>
@@ -3339,7 +3339,7 @@
       </p:sp>
       <p:sp>
         <p:nvSpPr>
-          <p:cNvPr id="10" name="Rectangle 9"/>
+          <p:cNvPr id="10" name="deckgen:decor"/>
           <p:cNvSpPr/>
           <p:nvPr/>
         </p:nvSpPr>
@@ -3599,7 +3599,7 @@
       <p:grpSpPr/>
       <p:sp>
         <p:nvSpPr>
-          <p:cNvPr id="2" name="Oval 1"/>
+          <p:cNvPr id="2" name="deckgen:decor"/>
           <p:cNvSpPr/>
           <p:nvPr/>
         </p:nvSpPr>
@@ -3629,7 +3629,7 @@
       </p:sp>
       <p:sp>
         <p:nvSpPr>
-          <p:cNvPr id="3" name="Oval 2"/>
+          <p:cNvPr id="3" name="deckgen:decor"/>
           <p:cNvSpPr/>
           <p:nvPr/>
         </p:nvSpPr>
@@ -3805,7 +3805,7 @@
                 <a:ea typeface="Pretendard"/>
                 <a:cs typeface="Pretendard"/>
               </a:rPr>
-              <a:t>4-1 의 Compose 에 REST 카탈로그와 Spark 를 더해, 방금 본 사슬이 실제로 돌아갈 자리를 만듭니다</a:t>
+              <a:t>4-1 의 Compose 를 통째로 바꿔 REST 카탈로그와 Spark 를 더하고, 방금 본 사슬이 돌아갈 자리를 만들어 보세요</a:t>
             </a:r>
           </a:p>
         </p:txBody>
@@ -3921,7 +3921,7 @@
                 <a:ea typeface="Pretendard"/>
                 <a:cs typeface="Pretendard"/>
               </a:rPr>
-              <a:t>docker-compose.yml 교체 · 컨테이너 넷</a:t>
+              <a:t>docker-compose.yml 통째로 교체 · 컨테이너 넷</a:t>
             </a:r>
           </a:p>
         </p:txBody>
@@ -4269,7 +4269,7 @@
                 <a:ea typeface="Pretendard"/>
                 <a:cs typeface="Pretendard"/>
               </a:rPr>
-              <a:t>spark-sql 에서 SHOW CATALOGS</a:t>
+              <a:t>SHOW CATALOGS · 카탈로그 멈춰 보기</a:t>
             </a:r>
           </a:p>
         </p:txBody>
@@ -4381,7 +4381,7 @@
                 <a:ea typeface="Pretendard"/>
                 <a:cs typeface="Pretendard"/>
               </a:rPr>
-              <a:t>minio 떠 있는 4-1 폴더 · 메모리 8GB</a:t>
+              <a:t>4-1 의 ~/lakehouse · 미리 받은 이미지 2개</a:t>
             </a:r>
           </a:p>
         </p:txBody>
@@ -4406,7 +4406,7 @@
       <p:grpSpPr/>
       <p:sp>
         <p:nvSpPr>
-          <p:cNvPr id="2" name="Oval 1"/>
+          <p:cNvPr id="2" name="deckgen:decor"/>
           <p:cNvSpPr/>
           <p:nvPr/>
         </p:nvSpPr>
@@ -4436,7 +4436,7 @@
       </p:sp>
       <p:sp>
         <p:nvSpPr>
-          <p:cNvPr id="3" name="Oval 2"/>
+          <p:cNvPr id="3" name="deckgen:decor"/>
           <p:cNvSpPr/>
           <p:nvPr/>
         </p:nvSpPr>
@@ -4466,7 +4466,7 @@
       </p:sp>
       <p:sp>
         <p:nvSpPr>
-          <p:cNvPr id="4" name="Oval 3"/>
+          <p:cNvPr id="4" name="deckgen:decor"/>
           <p:cNvSpPr/>
           <p:nvPr/>
         </p:nvSpPr>
@@ -5397,7 +5397,7 @@
       <p:grpSpPr/>
       <p:sp>
         <p:nvSpPr>
-          <p:cNvPr id="2" name="Oval 1"/>
+          <p:cNvPr id="2" name="deckgen:decor"/>
           <p:cNvSpPr/>
           <p:nvPr/>
         </p:nvSpPr>
@@ -5427,7 +5427,7 @@
       </p:sp>
       <p:sp>
         <p:nvSpPr>
-          <p:cNvPr id="3" name="Oval 2"/>
+          <p:cNvPr id="3" name="deckgen:decor"/>
           <p:cNvSpPr/>
           <p:nvPr/>
         </p:nvSpPr>
@@ -5457,7 +5457,7 @@
       </p:sp>
       <p:sp>
         <p:nvSpPr>
-          <p:cNvPr id="4" name="Oval 3"/>
+          <p:cNvPr id="4" name="deckgen:decor"/>
           <p:cNvSpPr/>
           <p:nvPr/>
         </p:nvSpPr>
@@ -7333,7 +7333,7 @@
       <p:grpSpPr/>
       <p:sp>
         <p:nvSpPr>
-          <p:cNvPr id="2" name="Oval 1"/>
+          <p:cNvPr id="2" name="deckgen:decor"/>
           <p:cNvSpPr/>
           <p:nvPr/>
         </p:nvSpPr>
@@ -7363,7 +7363,7 @@
       </p:sp>
       <p:sp>
         <p:nvSpPr>
-          <p:cNvPr id="3" name="Oval 2"/>
+          <p:cNvPr id="3" name="deckgen:decor"/>
           <p:cNvSpPr/>
           <p:nvPr/>
         </p:nvSpPr>
@@ -7393,7 +7393,7 @@
       </p:sp>
       <p:sp>
         <p:nvSpPr>
-          <p:cNvPr id="4" name="Oval 3"/>
+          <p:cNvPr id="4" name="deckgen:decor"/>
           <p:cNvSpPr/>
           <p:nvPr/>
         </p:nvSpPr>
@@ -8394,7 +8394,7 @@
       <p:grpSpPr/>
       <p:sp>
         <p:nvSpPr>
-          <p:cNvPr id="2" name="Oval 1"/>
+          <p:cNvPr id="2" name="deckgen:decor"/>
           <p:cNvSpPr/>
           <p:nvPr/>
         </p:nvSpPr>
@@ -8424,7 +8424,7 @@
       </p:sp>
       <p:sp>
         <p:nvSpPr>
-          <p:cNvPr id="3" name="Oval 2"/>
+          <p:cNvPr id="3" name="deckgen:decor"/>
           <p:cNvSpPr/>
           <p:nvPr/>
         </p:nvSpPr>
@@ -8454,7 +8454,7 @@
       </p:sp>
       <p:sp>
         <p:nvSpPr>
-          <p:cNvPr id="4" name="Oval 3"/>
+          <p:cNvPr id="4" name="deckgen:decor"/>
           <p:cNvSpPr/>
           <p:nvPr/>
         </p:nvSpPr>
@@ -9645,7 +9645,7 @@
                 <a:ea typeface="Pretendard"/>
                 <a:cs typeface="Pretendard"/>
               </a:rPr>
-              <a:t>각 층이 하는 일이 다르다 — 카탈로그 교체 = 트랜잭션 · 매니페스트 min/max = 안 읽어도 될 파일 건너뛰기 · 옛 스냅샷 = 타임 트래블</a:t>
+              <a:t>각 층이 하는 일이 다르다 — 카탈로그 포인터 교체 = 커밋 · 매니페스트 min/max = 안 읽어도 될 파일 건너뛰기 · 옛 스냅샷 = 타임 트래블</a:t>
             </a:r>
           </a:p>
         </p:txBody>
@@ -9782,7 +9782,7 @@
       <p:grpSpPr/>
       <p:sp>
         <p:nvSpPr>
-          <p:cNvPr id="2" name="Oval 1"/>
+          <p:cNvPr id="2" name="deckgen:decor"/>
           <p:cNvSpPr/>
           <p:nvPr/>
         </p:nvSpPr>
@@ -9812,7 +9812,7 @@
       </p:sp>
       <p:sp>
         <p:nvSpPr>
-          <p:cNvPr id="3" name="Oval 2"/>
+          <p:cNvPr id="3" name="deckgen:decor"/>
           <p:cNvSpPr/>
           <p:nvPr/>
         </p:nvSpPr>
@@ -9842,7 +9842,7 @@
       </p:sp>
       <p:sp>
         <p:nvSpPr>
-          <p:cNvPr id="4" name="Oval 3"/>
+          <p:cNvPr id="4" name="deckgen:decor"/>
           <p:cNvSpPr/>
           <p:nvPr/>
         </p:nvSpPr>
@@ -10123,7 +10123,7 @@
                 <a:ea typeface="Pretendard"/>
                 <a:cs typeface="Pretendard"/>
               </a:rPr>
-              <a:t>① 새 데이터 파일들을 쓴다</a:t>
+              <a:t>새 데이터 파일들을 쓴다</a:t>
             </a:r>
           </a:p>
         </p:txBody>
@@ -10310,7 +10310,7 @@
                 <a:ea typeface="Pretendard"/>
                 <a:cs typeface="Pretendard"/>
               </a:rPr>
-              <a:t>② 새 매니페스트를 쓴다</a:t>
+              <a:t>새 매니페스트를 쓴다</a:t>
             </a:r>
           </a:p>
         </p:txBody>
@@ -10497,7 +10497,7 @@
                 <a:ea typeface="Pretendard"/>
                 <a:cs typeface="Pretendard"/>
               </a:rPr>
-              <a:t>③ 새 스냅샷 메타데이터를 쓴다</a:t>
+              <a:t>새 스냅샷 메타데이터를 쓴다</a:t>
             </a:r>
           </a:p>
         </p:txBody>
@@ -10684,7 +10684,7 @@
                 <a:ea typeface="Pretendard"/>
                 <a:cs typeface="Pretendard"/>
               </a:rPr>
-              <a:t>④ 카탈로그의 포인터를 바꾼다</a:t>
+              <a:t>카탈로그의 포인터를 바꾼다</a:t>
             </a:r>
           </a:p>
         </p:txBody>
@@ -10841,7 +10841,7 @@
                 <a:ea typeface="Pretendard"/>
                 <a:cs typeface="Pretendard"/>
               </a:rPr>
-              <a:t>④ 가 없으니</a:t>
+              <a:t>4단계가 없으니</a:t>
             </a:r>
           </a:p>
           <a:p>
@@ -10996,7 +10996,7 @@
       <p:grpSpPr/>
       <p:sp>
         <p:nvSpPr>
-          <p:cNvPr id="2" name="Oval 1"/>
+          <p:cNvPr id="2" name="deckgen:decor"/>
           <p:cNvSpPr/>
           <p:nvPr/>
         </p:nvSpPr>
@@ -11026,7 +11026,7 @@
       </p:sp>
       <p:sp>
         <p:nvSpPr>
-          <p:cNvPr id="3" name="Oval 2"/>
+          <p:cNvPr id="3" name="deckgen:decor"/>
           <p:cNvSpPr/>
           <p:nvPr/>
         </p:nvSpPr>
@@ -11056,7 +11056,7 @@
       </p:sp>
       <p:sp>
         <p:nvSpPr>
-          <p:cNvPr id="4" name="Oval 3"/>
+          <p:cNvPr id="4" name="deckgen:decor"/>
           <p:cNvSpPr/>
           <p:nvPr/>
         </p:nvSpPr>
@@ -12932,7 +12932,7 @@
       <p:grpSpPr/>
       <p:sp>
         <p:nvSpPr>
-          <p:cNvPr id="2" name="Oval 1"/>
+          <p:cNvPr id="2" name="deckgen:decor"/>
           <p:cNvSpPr/>
           <p:nvPr/>
         </p:nvSpPr>
@@ -12962,7 +12962,7 @@
       </p:sp>
       <p:sp>
         <p:nvSpPr>
-          <p:cNvPr id="3" name="Oval 2"/>
+          <p:cNvPr id="3" name="deckgen:decor"/>
           <p:cNvSpPr/>
           <p:nvPr/>
         </p:nvSpPr>
@@ -12992,7 +12992,7 @@
       </p:sp>
       <p:sp>
         <p:nvSpPr>
-          <p:cNvPr id="4" name="Oval 3"/>
+          <p:cNvPr id="4" name="deckgen:decor"/>
           <p:cNvSpPr/>
           <p:nvPr/>
         </p:nvSpPr>
@@ -14506,7 +14506,7 @@
                 <a:ea typeface="Pretendard"/>
                 <a:cs typeface="Pretendard"/>
               </a:rPr>
-              <a:t>REST 를 쓰면 Spark 와 Trino 가 같은 카탈로그를 보게 할 수 있다 — 4-5 의 두 엔진 상호운용 검증에 필요</a:t>
+              <a:t>REST 는 Spark 와 Trino 가 같은 카탈로그를 보게 한다(4-5 상호운용 검증) — 오늘은 테이블 목록을 볼륨 안 파일에 보관</a:t>
             </a:r>
           </a:p>
         </p:txBody>
@@ -14643,7 +14643,7 @@
       <p:grpSpPr/>
       <p:sp>
         <p:nvSpPr>
-          <p:cNvPr id="2" name="Oval 1"/>
+          <p:cNvPr id="2" name="deckgen:decor"/>
           <p:cNvSpPr/>
           <p:nvPr/>
         </p:nvSpPr>
@@ -14673,7 +14673,7 @@
       </p:sp>
       <p:sp>
         <p:nvSpPr>
-          <p:cNvPr id="3" name="Oval 2"/>
+          <p:cNvPr id="3" name="deckgen:decor"/>
           <p:cNvSpPr/>
           <p:nvPr/>
         </p:nvSpPr>
@@ -14703,7 +14703,7 @@
       </p:sp>
       <p:sp>
         <p:nvSpPr>
-          <p:cNvPr id="4" name="Oval 3"/>
+          <p:cNvPr id="4" name="deckgen:decor"/>
           <p:cNvSpPr/>
           <p:nvPr/>
         </p:nvSpPr>

</xml_diff>